<commit_message>
Dominio holarocco.com: guía, plantilla de correo y runbooks
- Guía de inicio (PDF y PowerPoint) con holarocco.com.
- Plantilla del correo de acceso con la marca Rocco (docs/marca/correo-acceso.html).
- Runbooks al dominio nuevo; el webhook de Meta, el DNS y el remitente siguen en
  caja.jpsoftwaredev.com.

Co-Authored-By: Claude Opus 5.5 <noreply@anthropic.com>
Claude-Session: https://claude.ai/code/session_01JDwKA1YUHPBZPD6osqPUUD
</commit_message>
<xml_diff>
--- a/docs/marca/Rocco-Guia-de-inicio.pptx
+++ b/docs/marca/Rocco-Guia-de-inicio.pptx
@@ -795,7 +795,7 @@
           <a:lstStyle/>
           <a:p>
             <a:r>
-              <a:t>La política completa está en caja.jpsoftwaredev.com/privacidad.</a:t>
+              <a:t>La política completa está en holarocco.com/privacidad.</a:t>
             </a:r>
           </a:p>
         </p:txBody>
@@ -1005,7 +1005,7 @@
           <a:lstStyle/>
           <a:p>
             <a:r>
-              <a:t>Todo toma unos 2 minutos y se hace en el mismo chat, con botones. Si te equivocas, escribe «empezar de nuevo». ¿Prefieres la web? También puedes crear la cuenta en caja.jpsoftwaredev.com/registro. Nada se cobra durante la prueba.</a:t>
+              <a:t>Todo toma unos 2 minutos y se hace en el mismo chat, con botones. Si te equivocas, escribe «empezar de nuevo». ¿Prefieres la web? También puedes crear la cuenta en holarocco.com/registro. Nada se cobra durante la prueba.</a:t>
             </a:r>
           </a:p>
         </p:txBody>

</xml_diff>